<commit_message>
Deck: slide 13 bottom row shows one KPI per step and a 60-second live demo
The tiny control-tower thumbnails and the stats panel gave way to the
pilot KPI for each app step and a demo that shows the Factory Node
clearing the 8% badge at a ₹105 making cost (values from the prototype's
own price check; the build fails if that stops being true). Stats moved
into the live-link panel. v07 in deck/old is the deck before.

Co-Authored-By: Claude Opus 5.5 <noreply@anthropic.com>
</commit_message>
<xml_diff>
--- a/02_round2_detailed_submission/deck/rough_work/13_product_walkthrough/product_walkthrough.pptx
+++ b/02_round2_detailed_submission/deck/rough_work/13_product_walkthrough/product_walkthrough.pptx
@@ -8,7 +8,7 @@
     <p:notesMasterId r:id="rId17"/>
   </p:notesMasterIdLst>
   <p:sldIdLst>
-    <p:sldId id="719" r:id="rId14"/>
+    <p:sldId id="592" r:id="rId14"/>
   </p:sldIdLst>
   <p:sldSz cx="12192000" cy="6858000"/>
   <p:notesSz cx="6858000" cy="12192000"/>
@@ -283,7 +283,7 @@
           <a:p>
             <a:r>
               <a:rPr lang="en-IN" dirty="0"/>
-              <a:t>Product walkthrough. Eight screens of the manufacturer app (Price check, Demand Brief, Batch, WhatsApp), two per tab, captured from the live prototype; coral markers match the numbered lines. Screen values come from the prototype’s seeded synthetic data (Kavin Knit Mills, ₹98 making cost); the costed case in Unit Economics uses ₹80 and the ₹209 demand-weighted median. 13</a:t>
+              <a:t>Product walkthrough. Eight screens of the manufacturer app (Price check, Demand Brief, Batch, WhatsApp), two per tab, captured from the live prototype; coral markers match the numbered lines. Bottom row: the journey KPI that judges each step in the pilot, a one-minute live demo (making cost ₹105: Ship myself misses the 8% badge, the Factory Node clears it), and the live link. Screen values come from the prototype’s seeded synthetic data (Kavin Knit Mills, ₹98 making cost); the costed case in Unit Economics uses ₹80 and the ₹209 demand-weighted median. 13</a:t>
             </a:r>
           </a:p>
         </p:txBody>
@@ -4878,7 +4878,7 @@
                 <a:ea typeface="Calibri" pitchFamily="34" charset="-122"/>
                 <a:cs typeface="Calibri" pitchFamily="34" charset="-120"/>
               </a:rPr>
-              <a:t>Meesho’s side: the control tower (desktop, same link)</a:t>
+              <a:t>One KPI per step: how the pilot proves the app works</a:t>
             </a:r>
             <a:endParaRPr lang="en-US" sz="950" dirty="0"/>
           </a:p>
@@ -4911,7 +4911,7 @@
       </p:sp>
       <p:pic>
         <p:nvPicPr>
-          <p:cNvPr id="133" name="Image 15" descr="/Users/prathmeshwalimbe/Downloads/Meesho/02_round2_detailed_submission/deck/source/assets/icons/FaGaugeHigh_w.png">    </p:cNvPr>
+          <p:cNvPr id="133" name="Image 15" descr="/Users/prathmeshwalimbe/Downloads/Meesho/02_round2_detailed_submission/deck/source/assets/icons/FaFlagCheckered_w.png">    </p:cNvPr>
           <p:cNvPicPr>
             <a:picLocks noChangeAspect="1"/>
           </p:cNvPicPr>
@@ -4933,9 +4933,424 @@
           </a:prstGeom>
         </p:spPr>
       </p:pic>
+      <p:sp>
+        <p:nvSpPr>
+          <p:cNvPr id="134" name="Shape 116"/>
+          <p:cNvSpPr/>
+          <p:nvPr/>
+        </p:nvSpPr>
+        <p:spPr>
+          <a:xfrm>
+            <a:off x="612648" y="5602072"/>
+            <a:ext cx="1270010" cy="478688"/>
+          </a:xfrm>
+          <a:prstGeom prst="homePlate">
+            <a:avLst/>
+          </a:prstGeom>
+          <a:solidFill>
+            <a:srgbClr val="5A0A46"/>
+          </a:solidFill>
+          <a:ln w="12700">
+            <a:solidFill>
+              <a:srgbClr val="FFFFFF"/>
+            </a:solidFill>
+            <a:prstDash val="solid"/>
+          </a:ln>
+        </p:spPr>
+      </p:sp>
+      <p:sp>
+        <p:nvSpPr>
+          <p:cNvPr id="135" name="Text 117"/>
+          <p:cNvSpPr txBox="1"/>
+          <p:nvPr/>
+        </p:nvSpPr>
+        <p:spPr>
+          <a:xfrm>
+            <a:off x="676656" y="5602072"/>
+            <a:ext cx="986546" cy="478688"/>
+          </a:xfrm>
+          <a:prstGeom prst="rect">
+            <a:avLst/>
+          </a:prstGeom>
+          <a:noFill/>
+          <a:ln/>
+        </p:spPr>
+        <p:txBody>
+          <a:bodyPr wrap="square" lIns="0" tIns="0" rIns="0" bIns="0" rtlCol="0" anchor="ctr"/>
+          <a:lstStyle/>
+          <a:p>
+            <a:pPr indent="0" marL="0">
+              <a:buNone/>
+            </a:pPr>
+            <a:r>
+              <a:rPr lang="en-US" sz="750" b="1" dirty="0">
+                <a:solidFill>
+                  <a:srgbClr val="FFFFFF"/>
+                </a:solidFill>
+                <a:latin typeface="Calibri" pitchFamily="34" charset="0"/>
+                <a:ea typeface="Calibri" pitchFamily="34" charset="-122"/>
+                <a:cs typeface="Calibri" pitchFamily="34" charset="-120"/>
+              </a:rPr>
+              <a:t>Price check → listed</a:t>
+            </a:r>
+            <a:endParaRPr lang="en-US" sz="750" dirty="0"/>
+          </a:p>
+          <a:p>
+            <a:pPr indent="0" marL="0">
+              <a:buNone/>
+            </a:pPr>
+            <a:r>
+              <a:rPr lang="en-US" sz="750" dirty="0">
+                <a:solidFill>
+                  <a:srgbClr val="FFFFFF"/>
+                </a:solidFill>
+                <a:latin typeface="Calibri" pitchFamily="34" charset="0"/>
+                <a:ea typeface="Calibri" pitchFamily="34" charset="-122"/>
+                <a:cs typeface="Calibri" pitchFamily="34" charset="-120"/>
+              </a:rPr>
+              <a:t>≥ 50% list within 30 days</a:t>
+            </a:r>
+            <a:endParaRPr lang="en-US" sz="750" dirty="0"/>
+          </a:p>
+        </p:txBody>
+      </p:sp>
+      <p:sp>
+        <p:nvSpPr>
+          <p:cNvPr id="136" name="Shape 118"/>
+          <p:cNvSpPr/>
+          <p:nvPr/>
+        </p:nvSpPr>
+        <p:spPr>
+          <a:xfrm>
+            <a:off x="1919234" y="5602072"/>
+            <a:ext cx="1270010" cy="478688"/>
+          </a:xfrm>
+          <a:prstGeom prst="homePlate">
+            <a:avLst/>
+          </a:prstGeom>
+          <a:solidFill>
+            <a:srgbClr val="7B2A66"/>
+          </a:solidFill>
+          <a:ln w="12700">
+            <a:solidFill>
+              <a:srgbClr val="FFFFFF"/>
+            </a:solidFill>
+            <a:prstDash val="solid"/>
+          </a:ln>
+        </p:spPr>
+      </p:sp>
+      <p:sp>
+        <p:nvSpPr>
+          <p:cNvPr id="137" name="Text 119"/>
+          <p:cNvSpPr txBox="1"/>
+          <p:nvPr/>
+        </p:nvSpPr>
+        <p:spPr>
+          <a:xfrm>
+            <a:off x="1983242" y="5602072"/>
+            <a:ext cx="986546" cy="478688"/>
+          </a:xfrm>
+          <a:prstGeom prst="rect">
+            <a:avLst/>
+          </a:prstGeom>
+          <a:noFill/>
+          <a:ln/>
+        </p:spPr>
+        <p:txBody>
+          <a:bodyPr wrap="square" lIns="0" tIns="0" rIns="0" bIns="0" rtlCol="0" anchor="ctr"/>
+          <a:lstStyle/>
+          <a:p>
+            <a:pPr indent="0" marL="0">
+              <a:buNone/>
+            </a:pPr>
+            <a:r>
+              <a:rPr lang="en-US" sz="750" b="1" dirty="0">
+                <a:solidFill>
+                  <a:srgbClr val="FFFFFF"/>
+                </a:solidFill>
+                <a:latin typeface="Calibri" pitchFamily="34" charset="0"/>
+                <a:ea typeface="Calibri" pitchFamily="34" charset="-122"/>
+                <a:cs typeface="Calibri" pitchFamily="34" charset="-120"/>
+              </a:rPr>
+              <a:t>Demand Brief → batch</a:t>
+            </a:r>
+            <a:endParaRPr lang="en-US" sz="750" dirty="0"/>
+          </a:p>
+          <a:p>
+            <a:pPr indent="0" marL="0">
+              <a:buNone/>
+            </a:pPr>
+            <a:r>
+              <a:rPr lang="en-US" sz="750" dirty="0">
+                <a:solidFill>
+                  <a:srgbClr val="FFFFFF"/>
+                </a:solidFill>
+                <a:latin typeface="Calibri" pitchFamily="34" charset="0"/>
+                <a:ea typeface="Calibri" pitchFamily="34" charset="-122"/>
+                <a:cs typeface="Calibri" pitchFamily="34" charset="-120"/>
+              </a:rPr>
+              <a:t>first prepaid batch ≤ 14 days</a:t>
+            </a:r>
+            <a:endParaRPr lang="en-US" sz="750" dirty="0"/>
+          </a:p>
+        </p:txBody>
+      </p:sp>
+      <p:sp>
+        <p:nvSpPr>
+          <p:cNvPr id="138" name="Shape 120"/>
+          <p:cNvSpPr/>
+          <p:nvPr/>
+        </p:nvSpPr>
+        <p:spPr>
+          <a:xfrm>
+            <a:off x="3225820" y="5602072"/>
+            <a:ext cx="1270010" cy="478688"/>
+          </a:xfrm>
+          <a:prstGeom prst="homePlate">
+            <a:avLst/>
+          </a:prstGeom>
+          <a:solidFill>
+            <a:srgbClr val="E8434F"/>
+          </a:solidFill>
+          <a:ln w="12700">
+            <a:solidFill>
+              <a:srgbClr val="FFFFFF"/>
+            </a:solidFill>
+            <a:prstDash val="solid"/>
+          </a:ln>
+        </p:spPr>
+      </p:sp>
+      <p:sp>
+        <p:nvSpPr>
+          <p:cNvPr id="139" name="Text 121"/>
+          <p:cNvSpPr txBox="1"/>
+          <p:nvPr/>
+        </p:nvSpPr>
+        <p:spPr>
+          <a:xfrm>
+            <a:off x="3289828" y="5602072"/>
+            <a:ext cx="986546" cy="478688"/>
+          </a:xfrm>
+          <a:prstGeom prst="rect">
+            <a:avLst/>
+          </a:prstGeom>
+          <a:noFill/>
+          <a:ln/>
+        </p:spPr>
+        <p:txBody>
+          <a:bodyPr wrap="square" lIns="0" tIns="0" rIns="0" bIns="0" rtlCol="0" anchor="ctr"/>
+          <a:lstStyle/>
+          <a:p>
+            <a:pPr indent="0" marL="0">
+              <a:buNone/>
+            </a:pPr>
+            <a:r>
+              <a:rPr lang="en-US" sz="750" b="1" dirty="0">
+                <a:solidFill>
+                  <a:srgbClr val="FFFFFF"/>
+                </a:solidFill>
+                <a:latin typeface="Calibri" pitchFamily="34" charset="0"/>
+                <a:ea typeface="Calibri" pitchFamily="34" charset="-122"/>
+                <a:cs typeface="Calibri" pitchFamily="34" charset="-120"/>
+              </a:rPr>
+              <a:t>Batch → first orders</a:t>
+            </a:r>
+            <a:endParaRPr lang="en-US" sz="750" dirty="0"/>
+          </a:p>
+          <a:p>
+            <a:pPr indent="0" marL="0">
+              <a:buNone/>
+            </a:pPr>
+            <a:r>
+              <a:rPr lang="en-US" sz="750" dirty="0">
+                <a:solidFill>
+                  <a:srgbClr val="FFFFFF"/>
+                </a:solidFill>
+                <a:latin typeface="Calibri" pitchFamily="34" charset="0"/>
+                <a:ea typeface="Calibri" pitchFamily="34" charset="-122"/>
+                <a:cs typeface="Calibri" pitchFamily="34" charset="-120"/>
+              </a:rPr>
+              <a:t>≥ 60% of cohort orders at D7, D14</a:t>
+            </a:r>
+            <a:endParaRPr lang="en-US" sz="750" dirty="0"/>
+          </a:p>
+        </p:txBody>
+      </p:sp>
+      <p:sp>
+        <p:nvSpPr>
+          <p:cNvPr id="140" name="Shape 122"/>
+          <p:cNvSpPr/>
+          <p:nvPr/>
+        </p:nvSpPr>
+        <p:spPr>
+          <a:xfrm>
+            <a:off x="4532406" y="5602072"/>
+            <a:ext cx="1270010" cy="478688"/>
+          </a:xfrm>
+          <a:prstGeom prst="homePlate">
+            <a:avLst/>
+          </a:prstGeom>
+          <a:solidFill>
+            <a:srgbClr val="F7A21B"/>
+          </a:solidFill>
+          <a:ln w="12700">
+            <a:solidFill>
+              <a:srgbClr val="FFFFFF"/>
+            </a:solidFill>
+            <a:prstDash val="solid"/>
+          </a:ln>
+        </p:spPr>
+      </p:sp>
+      <p:sp>
+        <p:nvSpPr>
+          <p:cNvPr id="141" name="Text 123"/>
+          <p:cNvSpPr txBox="1"/>
+          <p:nvPr/>
+        </p:nvSpPr>
+        <p:spPr>
+          <a:xfrm>
+            <a:off x="4596414" y="5602072"/>
+            <a:ext cx="986546" cy="478688"/>
+          </a:xfrm>
+          <a:prstGeom prst="rect">
+            <a:avLst/>
+          </a:prstGeom>
+          <a:noFill/>
+          <a:ln/>
+        </p:spPr>
+        <p:txBody>
+          <a:bodyPr wrap="square" lIns="0" tIns="0" rIns="0" bIns="0" rtlCol="0" anchor="ctr"/>
+          <a:lstStyle/>
+          <a:p>
+            <a:pPr indent="0" marL="0">
+              <a:buNone/>
+            </a:pPr>
+            <a:r>
+              <a:rPr lang="en-US" sz="750" b="1" dirty="0">
+                <a:solidFill>
+                  <a:srgbClr val="5A0A46"/>
+                </a:solidFill>
+                <a:latin typeface="Calibri" pitchFamily="34" charset="0"/>
+                <a:ea typeface="Calibri" pitchFamily="34" charset="-122"/>
+                <a:cs typeface="Calibri" pitchFamily="34" charset="-120"/>
+              </a:rPr>
+              <a:t>WhatsApp → repeat</a:t>
+            </a:r>
+            <a:endParaRPr lang="en-US" sz="750" dirty="0"/>
+          </a:p>
+          <a:p>
+            <a:pPr indent="0" marL="0">
+              <a:buNone/>
+            </a:pPr>
+            <a:r>
+              <a:rPr lang="en-US" sz="750" dirty="0">
+                <a:solidFill>
+                  <a:srgbClr val="5A0A46"/>
+                </a:solidFill>
+                <a:latin typeface="Calibri" pitchFamily="34" charset="0"/>
+                <a:ea typeface="Calibri" pitchFamily="34" charset="-122"/>
+                <a:cs typeface="Calibri" pitchFamily="34" charset="-120"/>
+              </a:rPr>
+              <a:t>active at D90 ≥ 75%</a:t>
+            </a:r>
+            <a:endParaRPr lang="en-US" sz="750" dirty="0"/>
+          </a:p>
+        </p:txBody>
+      </p:sp>
+      <p:sp>
+        <p:nvSpPr>
+          <p:cNvPr id="142" name="Shape 124"/>
+          <p:cNvSpPr/>
+          <p:nvPr/>
+        </p:nvSpPr>
+        <p:spPr>
+          <a:xfrm>
+            <a:off x="5957865" y="5309464"/>
+            <a:ext cx="3332074" cy="228600"/>
+          </a:xfrm>
+          <a:prstGeom prst="roundRect">
+            <a:avLst>
+              <a:gd name="adj" fmla="val 20000"/>
+            </a:avLst>
+          </a:prstGeom>
+          <a:solidFill>
+            <a:srgbClr val="E8434F"/>
+          </a:solidFill>
+          <a:ln w="9525">
+            <a:solidFill>
+              <a:srgbClr val="E8434F"/>
+            </a:solidFill>
+            <a:prstDash val="solid"/>
+          </a:ln>
+        </p:spPr>
+      </p:sp>
+      <p:sp>
+        <p:nvSpPr>
+          <p:cNvPr id="143" name="Text 125"/>
+          <p:cNvSpPr txBox="1"/>
+          <p:nvPr/>
+        </p:nvSpPr>
+        <p:spPr>
+          <a:xfrm>
+            <a:off x="6021873" y="5309464"/>
+            <a:ext cx="3204058" cy="228600"/>
+          </a:xfrm>
+          <a:prstGeom prst="rect">
+            <a:avLst/>
+          </a:prstGeom>
+          <a:noFill/>
+          <a:ln/>
+        </p:spPr>
+        <p:txBody>
+          <a:bodyPr wrap="square" lIns="0" tIns="0" rIns="0" bIns="0" rtlCol="0" anchor="ctr"/>
+          <a:lstStyle/>
+          <a:p>
+            <a:pPr indent="0" marL="0">
+              <a:buNone/>
+            </a:pPr>
+            <a:r>
+              <a:rPr lang="en-US" sz="950" b="1" dirty="0">
+                <a:solidFill>
+                  <a:srgbClr val="FFFFFF"/>
+                </a:solidFill>
+                <a:latin typeface="Calibri" pitchFamily="34" charset="0"/>
+                <a:ea typeface="Calibri" pitchFamily="34" charset="-122"/>
+                <a:cs typeface="Calibri" pitchFamily="34" charset="-120"/>
+              </a:rPr>
+              <a:t>Try it in 60 seconds</a:t>
+            </a:r>
+            <a:endParaRPr lang="en-US" sz="950" dirty="0"/>
+          </a:p>
+        </p:txBody>
+      </p:sp>
+      <p:sp>
+        <p:nvSpPr>
+          <p:cNvPr id="144" name="Shape 126"/>
+          <p:cNvSpPr/>
+          <p:nvPr/>
+        </p:nvSpPr>
+        <p:spPr>
+          <a:xfrm>
+            <a:off x="5957865" y="5556352"/>
+            <a:ext cx="3332074" cy="570128"/>
+          </a:xfrm>
+          <a:prstGeom prst="rect">
+            <a:avLst/>
+          </a:prstGeom>
+          <a:solidFill>
+            <a:srgbClr val="FBF3F8"/>
+          </a:solidFill>
+          <a:ln w="9525">
+            <a:solidFill>
+              <a:srgbClr val="D8C2D0"/>
+            </a:solidFill>
+            <a:prstDash val="solid"/>
+          </a:ln>
+        </p:spPr>
+      </p:sp>
       <p:pic>
         <p:nvPicPr>
-          <p:cNvPr id="134" name="Image 16" descr="/Users/prathmeshwalimbe/Downloads/Meesho/02_round2_detailed_submission/deck/source/assets/shot_pti_scatter.png">    </p:cNvPr>
+          <p:cNvPr id="145" name="Image 16" descr="/Users/prathmeshwalimbe/Downloads/Meesho/02_round2_detailed_submission/deck/source/assets/icons/FaBolt_w.png">    </p:cNvPr>
           <p:cNvPicPr>
             <a:picLocks noChangeAspect="1"/>
           </p:cNvPicPr>
@@ -4949,8 +5364,8 @@
         </p:blipFill>
         <p:spPr>
           <a:xfrm>
-            <a:off x="612648" y="5602072"/>
-            <a:ext cx="686471" cy="478688"/>
+            <a:off x="9061338" y="5346040"/>
+            <a:ext cx="155448" cy="155448"/>
           </a:xfrm>
           <a:prstGeom prst="rect">
             <a:avLst/>
@@ -4959,14 +5374,39 @@
       </p:pic>
       <p:sp>
         <p:nvSpPr>
-          <p:cNvPr id="135" name="Text 116"/>
-          <p:cNvSpPr txBox="1"/>
-          <p:nvPr/>
-        </p:nvSpPr>
-        <p:spPr>
-          <a:xfrm>
-            <a:off x="1353983" y="5602072"/>
-            <a:ext cx="840377" cy="478688"/>
+          <p:cNvPr id="146" name="Shape 127"/>
+          <p:cNvSpPr/>
+          <p:nvPr/>
+        </p:nvSpPr>
+        <p:spPr>
+          <a:xfrm>
+            <a:off x="6026445" y="5602072"/>
+            <a:ext cx="137160" cy="137160"/>
+          </a:xfrm>
+          <a:prstGeom prst="ellipse">
+            <a:avLst/>
+          </a:prstGeom>
+          <a:solidFill>
+            <a:srgbClr val="E8434F"/>
+          </a:solidFill>
+          <a:ln w="12700">
+            <a:solidFill>
+              <a:srgbClr val="FFFFFF"/>
+            </a:solidFill>
+            <a:prstDash val="solid"/>
+          </a:ln>
+        </p:spPr>
+      </p:sp>
+      <p:sp>
+        <p:nvSpPr>
+          <p:cNvPr id="147" name="Text 128"/>
+          <p:cNvSpPr txBox="1"/>
+          <p:nvPr/>
+        </p:nvSpPr>
+        <p:spPr>
+          <a:xfrm>
+            <a:off x="6026445" y="5602072"/>
+            <a:ext cx="137160" cy="137160"/>
           </a:xfrm>
           <a:prstGeom prst="rect">
             <a:avLst/>
@@ -4978,22 +5418,147 @@
           <a:bodyPr wrap="square" lIns="0" tIns="0" rIns="0" bIns="0" rtlCol="0" anchor="ctr"/>
           <a:lstStyle/>
           <a:p>
+            <a:pPr algn="ctr" indent="0" marL="0">
+              <a:buNone/>
+            </a:pPr>
+            <a:r>
+              <a:rPr lang="en-US" sz="750" b="1" dirty="0">
+                <a:solidFill>
+                  <a:srgbClr val="FFFFFF"/>
+                </a:solidFill>
+                <a:latin typeface="Calibri" pitchFamily="34" charset="0"/>
+                <a:ea typeface="Calibri" pitchFamily="34" charset="-122"/>
+                <a:cs typeface="Calibri" pitchFamily="34" charset="-120"/>
+              </a:rPr>
+              <a:t>1</a:t>
+            </a:r>
+            <a:endParaRPr lang="en-US" sz="750" dirty="0"/>
+          </a:p>
+        </p:txBody>
+      </p:sp>
+      <p:sp>
+        <p:nvSpPr>
+          <p:cNvPr id="148" name="Text 129"/>
+          <p:cNvSpPr txBox="1"/>
+          <p:nvPr/>
+        </p:nvSpPr>
+        <p:spPr>
+          <a:xfrm>
+            <a:off x="6213897" y="5602072"/>
+            <a:ext cx="3012034" cy="128016"/>
+          </a:xfrm>
+          <a:prstGeom prst="rect">
+            <a:avLst/>
+          </a:prstGeom>
+          <a:noFill/>
+          <a:ln/>
+        </p:spPr>
+        <p:txBody>
+          <a:bodyPr wrap="square" lIns="0" tIns="0" rIns="0" bIns="0" rtlCol="0" anchor="t"/>
+          <a:lstStyle/>
+          <a:p>
             <a:pPr indent="0" marL="0">
               <a:buNone/>
             </a:pPr>
             <a:r>
+              <a:rPr lang="en-US" sz="750" dirty="0">
+                <a:solidFill>
+                  <a:srgbClr val="1F1F1F"/>
+                </a:solidFill>
+                <a:latin typeface="Calibri" pitchFamily="34" charset="0"/>
+                <a:ea typeface="Calibri" pitchFamily="34" charset="-122"/>
+                <a:cs typeface="Calibri" pitchFamily="34" charset="-120"/>
+              </a:rPr>
+              <a:t>Scan the QR and open the Manufacturer app tab.</a:t>
+            </a:r>
+            <a:endParaRPr lang="en-US" sz="750" dirty="0"/>
+          </a:p>
+        </p:txBody>
+      </p:sp>
+      <p:sp>
+        <p:nvSpPr>
+          <p:cNvPr id="149" name="Shape 130"/>
+          <p:cNvSpPr/>
+          <p:nvPr/>
+        </p:nvSpPr>
+        <p:spPr>
+          <a:xfrm>
+            <a:off x="6026445" y="5739232"/>
+            <a:ext cx="137160" cy="137160"/>
+          </a:xfrm>
+          <a:prstGeom prst="ellipse">
+            <a:avLst/>
+          </a:prstGeom>
+          <a:solidFill>
+            <a:srgbClr val="E8434F"/>
+          </a:solidFill>
+          <a:ln w="12700">
+            <a:solidFill>
+              <a:srgbClr val="FFFFFF"/>
+            </a:solidFill>
+            <a:prstDash val="solid"/>
+          </a:ln>
+        </p:spPr>
+      </p:sp>
+      <p:sp>
+        <p:nvSpPr>
+          <p:cNvPr id="150" name="Text 131"/>
+          <p:cNvSpPr txBox="1"/>
+          <p:nvPr/>
+        </p:nvSpPr>
+        <p:spPr>
+          <a:xfrm>
+            <a:off x="6026445" y="5739232"/>
+            <a:ext cx="137160" cy="137160"/>
+          </a:xfrm>
+          <a:prstGeom prst="rect">
+            <a:avLst/>
+          </a:prstGeom>
+          <a:noFill/>
+          <a:ln/>
+        </p:spPr>
+        <p:txBody>
+          <a:bodyPr wrap="square" lIns="0" tIns="0" rIns="0" bIns="0" rtlCol="0" anchor="ctr"/>
+          <a:lstStyle/>
+          <a:p>
+            <a:pPr algn="ctr" indent="0" marL="0">
+              <a:buNone/>
+            </a:pPr>
+            <a:r>
               <a:rPr lang="en-US" sz="750" b="1" dirty="0">
                 <a:solidFill>
-                  <a:srgbClr val="5A0A46"/>
-                </a:solidFill>
-                <a:latin typeface="Calibri" pitchFamily="34" charset="0"/>
-                <a:ea typeface="Calibri" pitchFamily="34" charset="-122"/>
-                <a:cs typeface="Calibri" pitchFamily="34" charset="-120"/>
-              </a:rPr>
-              <a:t>Price Truth Index</a:t>
+                  <a:srgbClr val="FFFFFF"/>
+                </a:solidFill>
+                <a:latin typeface="Calibri" pitchFamily="34" charset="0"/>
+                <a:ea typeface="Calibri" pitchFamily="34" charset="-122"/>
+                <a:cs typeface="Calibri" pitchFamily="34" charset="-120"/>
+              </a:rPr>
+              <a:t>2</a:t>
             </a:r>
             <a:endParaRPr lang="en-US" sz="750" dirty="0"/>
           </a:p>
+        </p:txBody>
+      </p:sp>
+      <p:sp>
+        <p:nvSpPr>
+          <p:cNvPr id="151" name="Text 132"/>
+          <p:cNvSpPr txBox="1"/>
+          <p:nvPr/>
+        </p:nvSpPr>
+        <p:spPr>
+          <a:xfrm>
+            <a:off x="6213897" y="5739232"/>
+            <a:ext cx="3012034" cy="219456"/>
+          </a:xfrm>
+          <a:prstGeom prst="rect">
+            <a:avLst/>
+          </a:prstGeom>
+          <a:noFill/>
+          <a:ln/>
+        </p:spPr>
+        <p:txBody>
+          <a:bodyPr wrap="square" lIns="0" tIns="0" rIns="0" bIns="0" rtlCol="0" anchor="t"/>
+          <a:lstStyle/>
           <a:p>
             <a:pPr indent="0" marL="0">
               <a:buNone/>
@@ -5007,15 +5572,209 @@
                 <a:ea typeface="Calibri" pitchFamily="34" charset="-122"/>
                 <a:cs typeface="Calibri" pitchFamily="34" charset="-120"/>
               </a:rPr>
-              <a:t>every seller above ₹5 cr scored; 7 of the 10 largest fail</a:t>
+              <a:t>Set making cost to ₹105 and pick Ship myself: Not yet, 7.5% below the market (the badge needs 8%).</a:t>
             </a:r>
             <a:endParaRPr lang="en-US" sz="750" dirty="0"/>
           </a:p>
         </p:txBody>
+      </p:sp>
+      <p:sp>
+        <p:nvSpPr>
+          <p:cNvPr id="152" name="Shape 133"/>
+          <p:cNvSpPr/>
+          <p:nvPr/>
+        </p:nvSpPr>
+        <p:spPr>
+          <a:xfrm>
+            <a:off x="6026445" y="5967832"/>
+            <a:ext cx="137160" cy="137160"/>
+          </a:xfrm>
+          <a:prstGeom prst="ellipse">
+            <a:avLst/>
+          </a:prstGeom>
+          <a:solidFill>
+            <a:srgbClr val="E8434F"/>
+          </a:solidFill>
+          <a:ln w="12700">
+            <a:solidFill>
+              <a:srgbClr val="FFFFFF"/>
+            </a:solidFill>
+            <a:prstDash val="solid"/>
+          </a:ln>
+        </p:spPr>
+      </p:sp>
+      <p:sp>
+        <p:nvSpPr>
+          <p:cNvPr id="153" name="Text 134"/>
+          <p:cNvSpPr txBox="1"/>
+          <p:nvPr/>
+        </p:nvSpPr>
+        <p:spPr>
+          <a:xfrm>
+            <a:off x="6026445" y="5967832"/>
+            <a:ext cx="137160" cy="137160"/>
+          </a:xfrm>
+          <a:prstGeom prst="rect">
+            <a:avLst/>
+          </a:prstGeom>
+          <a:noFill/>
+          <a:ln/>
+        </p:spPr>
+        <p:txBody>
+          <a:bodyPr wrap="square" lIns="0" tIns="0" rIns="0" bIns="0" rtlCol="0" anchor="ctr"/>
+          <a:lstStyle/>
+          <a:p>
+            <a:pPr algn="ctr" indent="0" marL="0">
+              <a:buNone/>
+            </a:pPr>
+            <a:r>
+              <a:rPr lang="en-US" sz="750" b="1" dirty="0">
+                <a:solidFill>
+                  <a:srgbClr val="FFFFFF"/>
+                </a:solidFill>
+                <a:latin typeface="Calibri" pitchFamily="34" charset="0"/>
+                <a:ea typeface="Calibri" pitchFamily="34" charset="-122"/>
+                <a:cs typeface="Calibri" pitchFamily="34" charset="-120"/>
+              </a:rPr>
+              <a:t>3</a:t>
+            </a:r>
+            <a:endParaRPr lang="en-US" sz="750" dirty="0"/>
+          </a:p>
+        </p:txBody>
+      </p:sp>
+      <p:sp>
+        <p:nvSpPr>
+          <p:cNvPr id="154" name="Text 135"/>
+          <p:cNvSpPr txBox="1"/>
+          <p:nvPr/>
+        </p:nvSpPr>
+        <p:spPr>
+          <a:xfrm>
+            <a:off x="6213897" y="5967832"/>
+            <a:ext cx="3012034" cy="128016"/>
+          </a:xfrm>
+          <a:prstGeom prst="rect">
+            <a:avLst/>
+          </a:prstGeom>
+          <a:noFill/>
+          <a:ln/>
+        </p:spPr>
+        <p:txBody>
+          <a:bodyPr wrap="square" lIns="0" tIns="0" rIns="0" bIns="0" rtlCol="0" anchor="t"/>
+          <a:lstStyle/>
+          <a:p>
+            <a:pPr indent="0" marL="0">
+              <a:buNone/>
+            </a:pPr>
+            <a:r>
+              <a:rPr lang="en-US" sz="750" dirty="0">
+                <a:solidFill>
+                  <a:srgbClr val="1F1F1F"/>
+                </a:solidFill>
+                <a:latin typeface="Calibri" pitchFamily="34" charset="0"/>
+                <a:ea typeface="Calibri" pitchFamily="34" charset="-122"/>
+                <a:cs typeface="Calibri" pitchFamily="34" charset="-120"/>
+              </a:rPr>
+              <a:t>Switch to Factory Node: Qualifies, 10.0% below.</a:t>
+            </a:r>
+            <a:endParaRPr lang="en-US" sz="750" dirty="0"/>
+          </a:p>
+        </p:txBody>
+      </p:sp>
+      <p:sp>
+        <p:nvSpPr>
+          <p:cNvPr id="155" name="Shape 136"/>
+          <p:cNvSpPr/>
+          <p:nvPr/>
+        </p:nvSpPr>
+        <p:spPr>
+          <a:xfrm>
+            <a:off x="9381378" y="5309464"/>
+            <a:ext cx="2578974" cy="228600"/>
+          </a:xfrm>
+          <a:prstGeom prst="roundRect">
+            <a:avLst>
+              <a:gd name="adj" fmla="val 20000"/>
+            </a:avLst>
+          </a:prstGeom>
+          <a:solidFill>
+            <a:srgbClr val="5A0A46"/>
+          </a:solidFill>
+          <a:ln w="9525">
+            <a:solidFill>
+              <a:srgbClr val="5A0A46"/>
+            </a:solidFill>
+            <a:prstDash val="solid"/>
+          </a:ln>
+        </p:spPr>
+      </p:sp>
+      <p:sp>
+        <p:nvSpPr>
+          <p:cNvPr id="156" name="Text 137"/>
+          <p:cNvSpPr txBox="1"/>
+          <p:nvPr/>
+        </p:nvSpPr>
+        <p:spPr>
+          <a:xfrm>
+            <a:off x="9445386" y="5309464"/>
+            <a:ext cx="2450958" cy="228600"/>
+          </a:xfrm>
+          <a:prstGeom prst="rect">
+            <a:avLst/>
+          </a:prstGeom>
+          <a:noFill/>
+          <a:ln/>
+        </p:spPr>
+        <p:txBody>
+          <a:bodyPr wrap="square" lIns="0" tIns="0" rIns="0" bIns="0" rtlCol="0" anchor="ctr"/>
+          <a:lstStyle/>
+          <a:p>
+            <a:pPr indent="0" marL="0">
+              <a:buNone/>
+            </a:pPr>
+            <a:r>
+              <a:rPr lang="en-US" sz="950" b="1" dirty="0">
+                <a:solidFill>
+                  <a:srgbClr val="FFFFFF"/>
+                </a:solidFill>
+                <a:latin typeface="Calibri" pitchFamily="34" charset="0"/>
+                <a:ea typeface="Calibri" pitchFamily="34" charset="-122"/>
+                <a:cs typeface="Calibri" pitchFamily="34" charset="-120"/>
+              </a:rPr>
+              <a:t>Open it live</a:t>
+            </a:r>
+            <a:endParaRPr lang="en-US" sz="950" dirty="0"/>
+          </a:p>
+        </p:txBody>
+      </p:sp>
+      <p:sp>
+        <p:nvSpPr>
+          <p:cNvPr id="157" name="Shape 138"/>
+          <p:cNvSpPr/>
+          <p:nvPr/>
+        </p:nvSpPr>
+        <p:spPr>
+          <a:xfrm>
+            <a:off x="9381378" y="5556352"/>
+            <a:ext cx="2578974" cy="570128"/>
+          </a:xfrm>
+          <a:prstGeom prst="rect">
+            <a:avLst/>
+          </a:prstGeom>
+          <a:solidFill>
+            <a:srgbClr val="FBF3F8"/>
+          </a:solidFill>
+          <a:ln w="9525">
+            <a:solidFill>
+              <a:srgbClr val="D8C2D0"/>
+            </a:solidFill>
+            <a:prstDash val="solid"/>
+          </a:ln>
+        </p:spPr>
       </p:sp>
       <p:pic>
         <p:nvPicPr>
-          <p:cNvPr id="136" name="Image 17" descr="/Users/prathmeshwalimbe/Downloads/Meesho/02_round2_detailed_submission/deck/source/assets/shot_day30_chart.png">    </p:cNvPr>
+          <p:cNvPr id="158" name="Image 17" descr="/Users/prathmeshwalimbe/Downloads/Meesho/02_round2_detailed_submission/deck/source/assets/icons/FaLink_w.png">    </p:cNvPr>
           <p:cNvPicPr>
             <a:picLocks noChangeAspect="1"/>
           </p:cNvPicPr>
@@ -5029,73 +5788,17 @@
         </p:blipFill>
         <p:spPr>
           <a:xfrm>
-            <a:off x="2285799" y="5602072"/>
-            <a:ext cx="911954" cy="478688"/>
+            <a:off x="11731752" y="5346040"/>
+            <a:ext cx="155448" cy="155448"/>
           </a:xfrm>
           <a:prstGeom prst="rect">
             <a:avLst/>
           </a:prstGeom>
         </p:spPr>
       </p:pic>
-      <p:sp>
-        <p:nvSpPr>
-          <p:cNvPr id="137" name="Text 117"/>
-          <p:cNvSpPr txBox="1"/>
-          <p:nvPr/>
-        </p:nvSpPr>
-        <p:spPr>
-          <a:xfrm>
-            <a:off x="3252617" y="5602072"/>
-            <a:ext cx="840377" cy="478688"/>
-          </a:xfrm>
-          <a:prstGeom prst="rect">
-            <a:avLst/>
-          </a:prstGeom>
-          <a:noFill/>
-          <a:ln/>
-        </p:spPr>
-        <p:txBody>
-          <a:bodyPr wrap="square" lIns="0" tIns="0" rIns="0" bIns="0" rtlCol="0" anchor="ctr"/>
-          <a:lstStyle/>
-          <a:p>
-            <a:pPr indent="0" marL="0">
-              <a:buNone/>
-            </a:pPr>
-            <a:r>
-              <a:rPr lang="en-US" sz="750" b="1" dirty="0">
-                <a:solidFill>
-                  <a:srgbClr val="5A0A46"/>
-                </a:solidFill>
-                <a:latin typeface="Calibri" pitchFamily="34" charset="0"/>
-                <a:ea typeface="Calibri" pitchFamily="34" charset="-122"/>
-                <a:cs typeface="Calibri" pitchFamily="34" charset="-120"/>
-              </a:rPr>
-              <a:t>Day-30 readout</a:t>
-            </a:r>
-            <a:endParaRPr lang="en-US" sz="750" dirty="0"/>
-          </a:p>
-          <a:p>
-            <a:pPr indent="0" marL="0">
-              <a:buNone/>
-            </a:pPr>
-            <a:r>
-              <a:rPr lang="en-US" sz="750" dirty="0">
-                <a:solidFill>
-                  <a:srgbClr val="1F1F1F"/>
-                </a:solidFill>
-                <a:latin typeface="Calibri" pitchFamily="34" charset="0"/>
-                <a:ea typeface="Calibri" pitchFamily="34" charset="-122"/>
-                <a:cs typeface="Calibri" pitchFamily="34" charset="-120"/>
-              </a:rPr>
-              <a:t>badge vs holdout: +18.2% → fund</a:t>
-            </a:r>
-            <a:endParaRPr lang="en-US" sz="750" dirty="0"/>
-          </a:p>
-        </p:txBody>
-      </p:sp>
       <p:pic>
         <p:nvPicPr>
-          <p:cNvPr id="138" name="Image 18" descr="/Users/prathmeshwalimbe/Downloads/Meesho/02_round2_detailed_submission/deck/source/assets/shot_health_detail.png">    </p:cNvPr>
+          <p:cNvPr id="159" name="Image 18" descr="/Users/prathmeshwalimbe/Downloads/Meesho/02_round2_detailed_submission/deck/source/assets/qr_live.png">    </p:cNvPr>
           <p:cNvPicPr>
             <a:picLocks noChangeAspect="1"/>
           </p:cNvPicPr>
@@ -5109,832 +5812,6 @@
         </p:blipFill>
         <p:spPr>
           <a:xfrm>
-            <a:off x="4184434" y="5602072"/>
-            <a:ext cx="613014" cy="478688"/>
-          </a:xfrm>
-          <a:prstGeom prst="rect">
-            <a:avLst/>
-          </a:prstGeom>
-        </p:spPr>
-      </p:pic>
-      <p:sp>
-        <p:nvSpPr>
-          <p:cNvPr id="139" name="Text 118"/>
-          <p:cNvSpPr txBox="1"/>
-          <p:nvPr/>
-        </p:nvSpPr>
-        <p:spPr>
-          <a:xfrm>
-            <a:off x="4852312" y="5602072"/>
-            <a:ext cx="840377" cy="478688"/>
-          </a:xfrm>
-          <a:prstGeom prst="rect">
-            <a:avLst/>
-          </a:prstGeom>
-          <a:noFill/>
-          <a:ln/>
-        </p:spPr>
-        <p:txBody>
-          <a:bodyPr wrap="square" lIns="0" tIns="0" rIns="0" bIns="0" rtlCol="0" anchor="ctr"/>
-          <a:lstStyle/>
-          <a:p>
-            <a:pPr indent="0" marL="0">
-              <a:buNone/>
-            </a:pPr>
-            <a:r>
-              <a:rPr lang="en-US" sz="750" b="1" dirty="0">
-                <a:solidFill>
-                  <a:srgbClr val="5A0A46"/>
-                </a:solidFill>
-                <a:latin typeface="Calibri" pitchFamily="34" charset="0"/>
-                <a:ea typeface="Calibri" pitchFamily="34" charset="-122"/>
-                <a:cs typeface="Calibri" pitchFamily="34" charset="-120"/>
-              </a:rPr>
-              <a:t>Seller Health Score</a:t>
-            </a:r>
-            <a:endParaRPr lang="en-US" sz="750" dirty="0"/>
-          </a:p>
-          <a:p>
-            <a:pPr indent="0" marL="0">
-              <a:buNone/>
-            </a:pPr>
-            <a:r>
-              <a:rPr lang="en-US" sz="750" dirty="0">
-                <a:solidFill>
-                  <a:srgbClr val="1F1F1F"/>
-                </a:solidFill>
-                <a:latin typeface="Calibri" pitchFamily="34" charset="0"/>
-                <a:ea typeface="Calibri" pitchFamily="34" charset="-122"/>
-                <a:cs typeface="Calibri" pitchFamily="34" charset="-120"/>
-              </a:rPr>
-              <a:t>five signals, the rule that fired, the next action</a:t>
-            </a:r>
-            <a:endParaRPr lang="en-US" sz="750" dirty="0"/>
-          </a:p>
-        </p:txBody>
-      </p:sp>
-      <p:sp>
-        <p:nvSpPr>
-          <p:cNvPr id="140" name="Shape 119"/>
-          <p:cNvSpPr/>
-          <p:nvPr/>
-        </p:nvSpPr>
-        <p:spPr>
-          <a:xfrm>
-            <a:off x="5957865" y="5309464"/>
-            <a:ext cx="3332074" cy="228600"/>
-          </a:xfrm>
-          <a:prstGeom prst="roundRect">
-            <a:avLst>
-              <a:gd name="adj" fmla="val 20000"/>
-            </a:avLst>
-          </a:prstGeom>
-          <a:solidFill>
-            <a:srgbClr val="E8434F"/>
-          </a:solidFill>
-          <a:ln w="9525">
-            <a:solidFill>
-              <a:srgbClr val="E8434F"/>
-            </a:solidFill>
-            <a:prstDash val="solid"/>
-          </a:ln>
-        </p:spPr>
-      </p:sp>
-      <p:sp>
-        <p:nvSpPr>
-          <p:cNvPr id="141" name="Text 120"/>
-          <p:cNvSpPr txBox="1"/>
-          <p:nvPr/>
-        </p:nvSpPr>
-        <p:spPr>
-          <a:xfrm>
-            <a:off x="6021873" y="5309464"/>
-            <a:ext cx="3204058" cy="228600"/>
-          </a:xfrm>
-          <a:prstGeom prst="rect">
-            <a:avLst/>
-          </a:prstGeom>
-          <a:noFill/>
-          <a:ln/>
-        </p:spPr>
-        <p:txBody>
-          <a:bodyPr wrap="square" lIns="0" tIns="0" rIns="0" bIns="0" rtlCol="0" anchor="ctr"/>
-          <a:lstStyle/>
-          <a:p>
-            <a:pPr indent="0" marL="0">
-              <a:buNone/>
-            </a:pPr>
-            <a:r>
-              <a:rPr lang="en-US" sz="950" b="1" dirty="0">
-                <a:solidFill>
-                  <a:srgbClr val="FFFFFF"/>
-                </a:solidFill>
-                <a:latin typeface="Calibri" pitchFamily="34" charset="0"/>
-                <a:ea typeface="Calibri" pitchFamily="34" charset="-122"/>
-                <a:cs typeface="Calibri" pitchFamily="34" charset="-120"/>
-              </a:rPr>
-              <a:t>What the prototype runs on</a:t>
-            </a:r>
-            <a:endParaRPr lang="en-US" sz="950" dirty="0"/>
-          </a:p>
-        </p:txBody>
-      </p:sp>
-      <p:sp>
-        <p:nvSpPr>
-          <p:cNvPr id="142" name="Shape 121"/>
-          <p:cNvSpPr/>
-          <p:nvPr/>
-        </p:nvSpPr>
-        <p:spPr>
-          <a:xfrm>
-            <a:off x="5957865" y="5556352"/>
-            <a:ext cx="3332074" cy="570128"/>
-          </a:xfrm>
-          <a:prstGeom prst="rect">
-            <a:avLst/>
-          </a:prstGeom>
-          <a:solidFill>
-            <a:srgbClr val="FBF3F8"/>
-          </a:solidFill>
-          <a:ln w="9525">
-            <a:solidFill>
-              <a:srgbClr val="D8C2D0"/>
-            </a:solidFill>
-            <a:prstDash val="solid"/>
-          </a:ln>
-        </p:spPr>
-      </p:sp>
-      <p:pic>
-        <p:nvPicPr>
-          <p:cNvPr id="143" name="Image 19" descr="/Users/prathmeshwalimbe/Downloads/Meesho/02_round2_detailed_submission/deck/source/assets/icons/FaFlask_w.png">    </p:cNvPr>
-          <p:cNvPicPr>
-            <a:picLocks noChangeAspect="1"/>
-          </p:cNvPicPr>
-          <p:nvPr/>
-        </p:nvPicPr>
-        <p:blipFill>
-          <a:blip r:embed="rId20"/>
-          <a:stretch>
-            <a:fillRect/>
-          </a:stretch>
-        </p:blipFill>
-        <p:spPr>
-          <a:xfrm>
-            <a:off x="9061338" y="5346040"/>
-            <a:ext cx="155448" cy="155448"/>
-          </a:xfrm>
-          <a:prstGeom prst="rect">
-            <a:avLst/>
-          </a:prstGeom>
-        </p:spPr>
-      </p:pic>
-      <p:sp>
-        <p:nvSpPr>
-          <p:cNvPr id="144" name="Shape 122"/>
-          <p:cNvSpPr/>
-          <p:nvPr/>
-        </p:nvSpPr>
-        <p:spPr>
-          <a:xfrm>
-            <a:off x="6021873" y="5602072"/>
-            <a:ext cx="219456" cy="219456"/>
-          </a:xfrm>
-          <a:prstGeom prst="roundRect">
-            <a:avLst>
-              <a:gd name="adj" fmla="val 16667"/>
-            </a:avLst>
-          </a:prstGeom>
-          <a:solidFill>
-            <a:srgbClr val="E8434F"/>
-          </a:solidFill>
-          <a:ln w="9525">
-            <a:solidFill>
-              <a:srgbClr val="E8434F"/>
-            </a:solidFill>
-            <a:prstDash val="solid"/>
-          </a:ln>
-        </p:spPr>
-      </p:sp>
-      <p:pic>
-        <p:nvPicPr>
-          <p:cNvPr id="145" name="Image 20" descr="/Users/prathmeshwalimbe/Downloads/Meesho/02_round2_detailed_submission/deck/source/assets/icons/FaIndustry_w.png">    </p:cNvPr>
-          <p:cNvPicPr>
-            <a:picLocks noChangeAspect="1"/>
-          </p:cNvPicPr>
-          <p:nvPr/>
-        </p:nvPicPr>
-        <p:blipFill>
-          <a:blip r:embed="rId21"/>
-          <a:stretch>
-            <a:fillRect/>
-          </a:stretch>
-        </p:blipFill>
-        <p:spPr>
-          <a:xfrm>
-            <a:off x="6058449" y="5638648"/>
-            <a:ext cx="146304" cy="146304"/>
-          </a:xfrm>
-          <a:prstGeom prst="rect">
-            <a:avLst/>
-          </a:prstGeom>
-        </p:spPr>
-      </p:pic>
-      <p:sp>
-        <p:nvSpPr>
-          <p:cNvPr id="146" name="Text 123"/>
-          <p:cNvSpPr txBox="1"/>
-          <p:nvPr/>
-        </p:nvSpPr>
-        <p:spPr>
-          <a:xfrm>
-            <a:off x="6277905" y="5583784"/>
-            <a:ext cx="503834" cy="256032"/>
-          </a:xfrm>
-          <a:prstGeom prst="rect">
-            <a:avLst/>
-          </a:prstGeom>
-          <a:noFill/>
-          <a:ln/>
-        </p:spPr>
-        <p:txBody>
-          <a:bodyPr wrap="square" lIns="0" tIns="0" rIns="0" bIns="0" rtlCol="0" anchor="ctr"/>
-          <a:lstStyle/>
-          <a:p>
-            <a:pPr indent="0" marL="0">
-              <a:buNone/>
-            </a:pPr>
-            <a:r>
-              <a:rPr lang="en-US" sz="1100" b="1" dirty="0">
-                <a:solidFill>
-                  <a:srgbClr val="E8434F"/>
-                </a:solidFill>
-                <a:latin typeface="Arial" pitchFamily="34" charset="0"/>
-                <a:ea typeface="Arial" pitchFamily="34" charset="-122"/>
-                <a:cs typeface="Arial" pitchFamily="34" charset="-120"/>
-              </a:rPr>
-              <a:t>261</a:t>
-            </a:r>
-            <a:endParaRPr lang="en-US" sz="1100" dirty="0"/>
-          </a:p>
-        </p:txBody>
-      </p:sp>
-      <p:sp>
-        <p:nvSpPr>
-          <p:cNvPr id="147" name="Text 124"/>
-          <p:cNvSpPr txBox="1"/>
-          <p:nvPr/>
-        </p:nvSpPr>
-        <p:spPr>
-          <a:xfrm>
-            <a:off x="6021873" y="5848960"/>
-            <a:ext cx="759866" cy="231800"/>
-          </a:xfrm>
-          <a:prstGeom prst="rect">
-            <a:avLst/>
-          </a:prstGeom>
-          <a:noFill/>
-          <a:ln/>
-        </p:spPr>
-        <p:txBody>
-          <a:bodyPr wrap="square" lIns="0" tIns="0" rIns="0" bIns="0" rtlCol="0" anchor="t"/>
-          <a:lstStyle/>
-          <a:p>
-            <a:pPr indent="0" marL="0">
-              <a:buNone/>
-            </a:pPr>
-            <a:r>
-              <a:rPr lang="en-US" sz="700" dirty="0">
-                <a:solidFill>
-                  <a:srgbClr val="6B6B6B"/>
-                </a:solidFill>
-                <a:latin typeface="Calibri" pitchFamily="34" charset="0"/>
-                <a:ea typeface="Calibri" pitchFamily="34" charset="-122"/>
-                <a:cs typeface="Calibri" pitchFamily="34" charset="-120"/>
-              </a:rPr>
-              <a:t>synthetic sellers</a:t>
-            </a:r>
-            <a:endParaRPr lang="en-US" sz="700" dirty="0"/>
-          </a:p>
-        </p:txBody>
-      </p:sp>
-      <p:sp>
-        <p:nvSpPr>
-          <p:cNvPr id="148" name="Shape 125"/>
-          <p:cNvSpPr/>
-          <p:nvPr/>
-        </p:nvSpPr>
-        <p:spPr>
-          <a:xfrm>
-            <a:off x="6836603" y="5602072"/>
-            <a:ext cx="219456" cy="219456"/>
-          </a:xfrm>
-          <a:prstGeom prst="roundRect">
-            <a:avLst>
-              <a:gd name="adj" fmla="val 16667"/>
-            </a:avLst>
-          </a:prstGeom>
-          <a:solidFill>
-            <a:srgbClr val="F7A21B"/>
-          </a:solidFill>
-          <a:ln w="9525">
-            <a:solidFill>
-              <a:srgbClr val="F7A21B"/>
-            </a:solidFill>
-            <a:prstDash val="solid"/>
-          </a:ln>
-        </p:spPr>
-      </p:sp>
-      <p:pic>
-        <p:nvPicPr>
-          <p:cNvPr id="149" name="Image 21" descr="/Users/prathmeshwalimbe/Downloads/Meesho/02_round2_detailed_submission/deck/source/assets/icons/FaStore_w.png">    </p:cNvPr>
-          <p:cNvPicPr>
-            <a:picLocks noChangeAspect="1"/>
-          </p:cNvPicPr>
-          <p:nvPr/>
-        </p:nvPicPr>
-        <p:blipFill>
-          <a:blip r:embed="rId22"/>
-          <a:stretch>
-            <a:fillRect/>
-          </a:stretch>
-        </p:blipFill>
-        <p:spPr>
-          <a:xfrm>
-            <a:off x="6873179" y="5638648"/>
-            <a:ext cx="146304" cy="146304"/>
-          </a:xfrm>
-          <a:prstGeom prst="rect">
-            <a:avLst/>
-          </a:prstGeom>
-        </p:spPr>
-      </p:pic>
-      <p:sp>
-        <p:nvSpPr>
-          <p:cNvPr id="150" name="Text 126"/>
-          <p:cNvSpPr txBox="1"/>
-          <p:nvPr/>
-        </p:nvSpPr>
-        <p:spPr>
-          <a:xfrm>
-            <a:off x="7092635" y="5583784"/>
-            <a:ext cx="503834" cy="256032"/>
-          </a:xfrm>
-          <a:prstGeom prst="rect">
-            <a:avLst/>
-          </a:prstGeom>
-          <a:noFill/>
-          <a:ln/>
-        </p:spPr>
-        <p:txBody>
-          <a:bodyPr wrap="square" lIns="0" tIns="0" rIns="0" bIns="0" rtlCol="0" anchor="ctr"/>
-          <a:lstStyle/>
-          <a:p>
-            <a:pPr indent="0" marL="0">
-              <a:buNone/>
-            </a:pPr>
-            <a:r>
-              <a:rPr lang="en-US" sz="1100" b="1" dirty="0">
-                <a:solidFill>
-                  <a:srgbClr val="C27C0E"/>
-                </a:solidFill>
-                <a:latin typeface="Arial" pitchFamily="34" charset="0"/>
-                <a:ea typeface="Arial" pitchFamily="34" charset="-122"/>
-                <a:cs typeface="Arial" pitchFamily="34" charset="-120"/>
-              </a:rPr>
-              <a:t>4,415</a:t>
-            </a:r>
-            <a:endParaRPr lang="en-US" sz="1100" dirty="0"/>
-          </a:p>
-        </p:txBody>
-      </p:sp>
-      <p:sp>
-        <p:nvSpPr>
-          <p:cNvPr id="151" name="Text 127"/>
-          <p:cNvSpPr txBox="1"/>
-          <p:nvPr/>
-        </p:nvSpPr>
-        <p:spPr>
-          <a:xfrm>
-            <a:off x="6836603" y="5848960"/>
-            <a:ext cx="759866" cy="231800"/>
-          </a:xfrm>
-          <a:prstGeom prst="rect">
-            <a:avLst/>
-          </a:prstGeom>
-          <a:noFill/>
-          <a:ln/>
-        </p:spPr>
-        <p:txBody>
-          <a:bodyPr wrap="square" lIns="0" tIns="0" rIns="0" bIns="0" rtlCol="0" anchor="t"/>
-          <a:lstStyle/>
-          <a:p>
-            <a:pPr indent="0" marL="0">
-              <a:buNone/>
-            </a:pPr>
-            <a:r>
-              <a:rPr lang="en-US" sz="700" dirty="0">
-                <a:solidFill>
-                  <a:srgbClr val="6B6B6B"/>
-                </a:solidFill>
-                <a:latin typeface="Calibri" pitchFamily="34" charset="0"/>
-                <a:ea typeface="Calibri" pitchFamily="34" charset="-122"/>
-                <a:cs typeface="Calibri" pitchFamily="34" charset="-120"/>
-              </a:rPr>
-              <a:t>SKUs listed</a:t>
-            </a:r>
-            <a:endParaRPr lang="en-US" sz="700" dirty="0"/>
-          </a:p>
-        </p:txBody>
-      </p:sp>
-      <p:sp>
-        <p:nvSpPr>
-          <p:cNvPr id="152" name="Shape 128"/>
-          <p:cNvSpPr/>
-          <p:nvPr/>
-        </p:nvSpPr>
-        <p:spPr>
-          <a:xfrm>
-            <a:off x="7651333" y="5602072"/>
-            <a:ext cx="219456" cy="219456"/>
-          </a:xfrm>
-          <a:prstGeom prst="roundRect">
-            <a:avLst>
-              <a:gd name="adj" fmla="val 16667"/>
-            </a:avLst>
-          </a:prstGeom>
-          <a:solidFill>
-            <a:srgbClr val="5A0A46"/>
-          </a:solidFill>
-          <a:ln w="9525">
-            <a:solidFill>
-              <a:srgbClr val="5A0A46"/>
-            </a:solidFill>
-            <a:prstDash val="solid"/>
-          </a:ln>
-        </p:spPr>
-      </p:sp>
-      <p:pic>
-        <p:nvPicPr>
-          <p:cNvPr id="153" name="Image 22" descr="/Users/prathmeshwalimbe/Downloads/Meesho/02_round2_detailed_submission/deck/source/assets/icons/FaClipboardCheck_w.png">    </p:cNvPr>
-          <p:cNvPicPr>
-            <a:picLocks noChangeAspect="1"/>
-          </p:cNvPicPr>
-          <p:nvPr/>
-        </p:nvPicPr>
-        <p:blipFill>
-          <a:blip r:embed="rId23"/>
-          <a:stretch>
-            <a:fillRect/>
-          </a:stretch>
-        </p:blipFill>
-        <p:spPr>
-          <a:xfrm>
-            <a:off x="7687909" y="5638648"/>
-            <a:ext cx="146304" cy="146304"/>
-          </a:xfrm>
-          <a:prstGeom prst="rect">
-            <a:avLst/>
-          </a:prstGeom>
-        </p:spPr>
-      </p:pic>
-      <p:sp>
-        <p:nvSpPr>
-          <p:cNvPr id="154" name="Text 129"/>
-          <p:cNvSpPr txBox="1"/>
-          <p:nvPr/>
-        </p:nvSpPr>
-        <p:spPr>
-          <a:xfrm>
-            <a:off x="7907365" y="5583784"/>
-            <a:ext cx="503834" cy="256032"/>
-          </a:xfrm>
-          <a:prstGeom prst="rect">
-            <a:avLst/>
-          </a:prstGeom>
-          <a:noFill/>
-          <a:ln/>
-        </p:spPr>
-        <p:txBody>
-          <a:bodyPr wrap="square" lIns="0" tIns="0" rIns="0" bIns="0" rtlCol="0" anchor="ctr"/>
-          <a:lstStyle/>
-          <a:p>
-            <a:pPr indent="0" marL="0">
-              <a:buNone/>
-            </a:pPr>
-            <a:r>
-              <a:rPr lang="en-US" sz="1100" b="1" dirty="0">
-                <a:solidFill>
-                  <a:srgbClr val="5A0A46"/>
-                </a:solidFill>
-                <a:latin typeface="Arial" pitchFamily="34" charset="0"/>
-                <a:ea typeface="Arial" pitchFamily="34" charset="-122"/>
-                <a:cs typeface="Arial" pitchFamily="34" charset="-120"/>
-              </a:rPr>
-              <a:t>9</a:t>
-            </a:r>
-            <a:endParaRPr lang="en-US" sz="1100" dirty="0"/>
-          </a:p>
-        </p:txBody>
-      </p:sp>
-      <p:sp>
-        <p:nvSpPr>
-          <p:cNvPr id="155" name="Text 130"/>
-          <p:cNvSpPr txBox="1"/>
-          <p:nvPr/>
-        </p:nvSpPr>
-        <p:spPr>
-          <a:xfrm>
-            <a:off x="7651333" y="5848960"/>
-            <a:ext cx="759866" cy="231800"/>
-          </a:xfrm>
-          <a:prstGeom prst="rect">
-            <a:avLst/>
-          </a:prstGeom>
-          <a:noFill/>
-          <a:ln/>
-        </p:spPr>
-        <p:txBody>
-          <a:bodyPr wrap="square" lIns="0" tIns="0" rIns="0" bIns="0" rtlCol="0" anchor="t"/>
-          <a:lstStyle/>
-          <a:p>
-            <a:pPr indent="0" marL="0">
-              <a:buNone/>
-            </a:pPr>
-            <a:r>
-              <a:rPr lang="en-US" sz="700" dirty="0">
-                <a:solidFill>
-                  <a:srgbClr val="6B6B6B"/>
-                </a:solidFill>
-                <a:latin typeface="Calibri" pitchFamily="34" charset="0"/>
-                <a:ea typeface="Calibri" pitchFamily="34" charset="-122"/>
-                <a:cs typeface="Calibri" pitchFamily="34" charset="-120"/>
-              </a:rPr>
-              <a:t>C2M categories</a:t>
-            </a:r>
-            <a:endParaRPr lang="en-US" sz="700" dirty="0"/>
-          </a:p>
-        </p:txBody>
-      </p:sp>
-      <p:sp>
-        <p:nvSpPr>
-          <p:cNvPr id="156" name="Shape 131"/>
-          <p:cNvSpPr/>
-          <p:nvPr/>
-        </p:nvSpPr>
-        <p:spPr>
-          <a:xfrm>
-            <a:off x="8466064" y="5602072"/>
-            <a:ext cx="219456" cy="219456"/>
-          </a:xfrm>
-          <a:prstGeom prst="roundRect">
-            <a:avLst>
-              <a:gd name="adj" fmla="val 16667"/>
-            </a:avLst>
-          </a:prstGeom>
-          <a:solidFill>
-            <a:srgbClr val="2E9E5B"/>
-          </a:solidFill>
-          <a:ln w="9525">
-            <a:solidFill>
-              <a:srgbClr val="2E9E5B"/>
-            </a:solidFill>
-            <a:prstDash val="solid"/>
-          </a:ln>
-        </p:spPr>
-      </p:sp>
-      <p:pic>
-        <p:nvPicPr>
-          <p:cNvPr id="157" name="Image 23" descr="/Users/prathmeshwalimbe/Downloads/Meesho/02_round2_detailed_submission/deck/source/assets/icons/FaFlask_w.png">    </p:cNvPr>
-          <p:cNvPicPr>
-            <a:picLocks noChangeAspect="1"/>
-          </p:cNvPicPr>
-          <p:nvPr/>
-        </p:nvPicPr>
-        <p:blipFill>
-          <a:blip r:embed="rId24"/>
-          <a:stretch>
-            <a:fillRect/>
-          </a:stretch>
-        </p:blipFill>
-        <p:spPr>
-          <a:xfrm>
-            <a:off x="8502640" y="5638648"/>
-            <a:ext cx="146304" cy="146304"/>
-          </a:xfrm>
-          <a:prstGeom prst="rect">
-            <a:avLst/>
-          </a:prstGeom>
-        </p:spPr>
-      </p:pic>
-      <p:sp>
-        <p:nvSpPr>
-          <p:cNvPr id="158" name="Text 132"/>
-          <p:cNvSpPr txBox="1"/>
-          <p:nvPr/>
-        </p:nvSpPr>
-        <p:spPr>
-          <a:xfrm>
-            <a:off x="8722096" y="5583784"/>
-            <a:ext cx="503834" cy="256032"/>
-          </a:xfrm>
-          <a:prstGeom prst="rect">
-            <a:avLst/>
-          </a:prstGeom>
-          <a:noFill/>
-          <a:ln/>
-        </p:spPr>
-        <p:txBody>
-          <a:bodyPr wrap="square" lIns="0" tIns="0" rIns="0" bIns="0" rtlCol="0" anchor="ctr"/>
-          <a:lstStyle/>
-          <a:p>
-            <a:pPr indent="0" marL="0">
-              <a:buNone/>
-            </a:pPr>
-            <a:r>
-              <a:rPr lang="en-US" sz="1100" b="1" dirty="0">
-                <a:solidFill>
-                  <a:srgbClr val="2E9E5B"/>
-                </a:solidFill>
-                <a:latin typeface="Arial" pitchFamily="34" charset="0"/>
-                <a:ea typeface="Arial" pitchFamily="34" charset="-122"/>
-                <a:cs typeface="Arial" pitchFamily="34" charset="-120"/>
-              </a:rPr>
-              <a:t>4</a:t>
-            </a:r>
-            <a:endParaRPr lang="en-US" sz="1100" dirty="0"/>
-          </a:p>
-        </p:txBody>
-      </p:sp>
-      <p:sp>
-        <p:nvSpPr>
-          <p:cNvPr id="159" name="Text 133"/>
-          <p:cNvSpPr txBox="1"/>
-          <p:nvPr/>
-        </p:nvSpPr>
-        <p:spPr>
-          <a:xfrm>
-            <a:off x="8466064" y="5848960"/>
-            <a:ext cx="759866" cy="231800"/>
-          </a:xfrm>
-          <a:prstGeom prst="rect">
-            <a:avLst/>
-          </a:prstGeom>
-          <a:noFill/>
-          <a:ln/>
-        </p:spPr>
-        <p:txBody>
-          <a:bodyPr wrap="square" lIns="0" tIns="0" rIns="0" bIns="0" rtlCol="0" anchor="t"/>
-          <a:lstStyle/>
-          <a:p>
-            <a:pPr indent="0" marL="0">
-              <a:buNone/>
-            </a:pPr>
-            <a:r>
-              <a:rPr lang="en-US" sz="700" dirty="0">
-                <a:solidFill>
-                  <a:srgbClr val="6B6B6B"/>
-                </a:solidFill>
-                <a:latin typeface="Calibri" pitchFamily="34" charset="0"/>
-                <a:ea typeface="Calibri" pitchFamily="34" charset="-122"/>
-                <a:cs typeface="Calibri" pitchFamily="34" charset="-120"/>
-              </a:rPr>
-              <a:t>model tests before every deploy</a:t>
-            </a:r>
-            <a:endParaRPr lang="en-US" sz="700" dirty="0"/>
-          </a:p>
-        </p:txBody>
-      </p:sp>
-      <p:sp>
-        <p:nvSpPr>
-          <p:cNvPr id="160" name="Shape 134"/>
-          <p:cNvSpPr/>
-          <p:nvPr/>
-        </p:nvSpPr>
-        <p:spPr>
-          <a:xfrm>
-            <a:off x="9381378" y="5309464"/>
-            <a:ext cx="2578974" cy="228600"/>
-          </a:xfrm>
-          <a:prstGeom prst="roundRect">
-            <a:avLst>
-              <a:gd name="adj" fmla="val 20000"/>
-            </a:avLst>
-          </a:prstGeom>
-          <a:solidFill>
-            <a:srgbClr val="5A0A46"/>
-          </a:solidFill>
-          <a:ln w="9525">
-            <a:solidFill>
-              <a:srgbClr val="5A0A46"/>
-            </a:solidFill>
-            <a:prstDash val="solid"/>
-          </a:ln>
-        </p:spPr>
-      </p:sp>
-      <p:sp>
-        <p:nvSpPr>
-          <p:cNvPr id="161" name="Text 135"/>
-          <p:cNvSpPr txBox="1"/>
-          <p:nvPr/>
-        </p:nvSpPr>
-        <p:spPr>
-          <a:xfrm>
-            <a:off x="9445386" y="5309464"/>
-            <a:ext cx="2450958" cy="228600"/>
-          </a:xfrm>
-          <a:prstGeom prst="rect">
-            <a:avLst/>
-          </a:prstGeom>
-          <a:noFill/>
-          <a:ln/>
-        </p:spPr>
-        <p:txBody>
-          <a:bodyPr wrap="square" lIns="0" tIns="0" rIns="0" bIns="0" rtlCol="0" anchor="ctr"/>
-          <a:lstStyle/>
-          <a:p>
-            <a:pPr indent="0" marL="0">
-              <a:buNone/>
-            </a:pPr>
-            <a:r>
-              <a:rPr lang="en-US" sz="950" b="1" dirty="0">
-                <a:solidFill>
-                  <a:srgbClr val="FFFFFF"/>
-                </a:solidFill>
-                <a:latin typeface="Calibri" pitchFamily="34" charset="0"/>
-                <a:ea typeface="Calibri" pitchFamily="34" charset="-122"/>
-                <a:cs typeface="Calibri" pitchFamily="34" charset="-120"/>
-              </a:rPr>
-              <a:t>Open it live</a:t>
-            </a:r>
-            <a:endParaRPr lang="en-US" sz="950" dirty="0"/>
-          </a:p>
-        </p:txBody>
-      </p:sp>
-      <p:sp>
-        <p:nvSpPr>
-          <p:cNvPr id="162" name="Shape 136"/>
-          <p:cNvSpPr/>
-          <p:nvPr/>
-        </p:nvSpPr>
-        <p:spPr>
-          <a:xfrm>
-            <a:off x="9381378" y="5556352"/>
-            <a:ext cx="2578974" cy="570128"/>
-          </a:xfrm>
-          <a:prstGeom prst="rect">
-            <a:avLst/>
-          </a:prstGeom>
-          <a:solidFill>
-            <a:srgbClr val="FBF3F8"/>
-          </a:solidFill>
-          <a:ln w="9525">
-            <a:solidFill>
-              <a:srgbClr val="D8C2D0"/>
-            </a:solidFill>
-            <a:prstDash val="solid"/>
-          </a:ln>
-        </p:spPr>
-      </p:sp>
-      <p:pic>
-        <p:nvPicPr>
-          <p:cNvPr id="163" name="Image 24" descr="/Users/prathmeshwalimbe/Downloads/Meesho/02_round2_detailed_submission/deck/source/assets/icons/FaLink_w.png">    </p:cNvPr>
-          <p:cNvPicPr>
-            <a:picLocks noChangeAspect="1"/>
-          </p:cNvPicPr>
-          <p:nvPr/>
-        </p:nvPicPr>
-        <p:blipFill>
-          <a:blip r:embed="rId25"/>
-          <a:stretch>
-            <a:fillRect/>
-          </a:stretch>
-        </p:blipFill>
-        <p:spPr>
-          <a:xfrm>
-            <a:off x="11731752" y="5346040"/>
-            <a:ext cx="155448" cy="155448"/>
-          </a:xfrm>
-          <a:prstGeom prst="rect">
-            <a:avLst/>
-          </a:prstGeom>
-        </p:spPr>
-      </p:pic>
-      <p:pic>
-        <p:nvPicPr>
-          <p:cNvPr id="164" name="Image 25" descr="/Users/prathmeshwalimbe/Downloads/Meesho/02_round2_detailed_submission/deck/source/assets/qr_live.png">    </p:cNvPr>
-          <p:cNvPicPr>
-            <a:picLocks noChangeAspect="1"/>
-          </p:cNvPicPr>
-          <p:nvPr/>
-        </p:nvPicPr>
-        <p:blipFill>
-          <a:blip r:embed="rId26"/>
-          <a:stretch>
-            <a:fillRect/>
-          </a:stretch>
-        </p:blipFill>
-        <p:spPr>
-          <a:xfrm>
             <a:off x="9445386" y="5602072"/>
             <a:ext cx="478688" cy="478688"/>
           </a:xfrm>
@@ -5945,14 +5822,14 @@
       </p:pic>
       <p:sp>
         <p:nvSpPr>
-          <p:cNvPr id="165" name="Text 137"/>
-          <p:cNvSpPr txBox="1"/>
-          <p:nvPr/>
-        </p:nvSpPr>
-        <p:spPr>
-          <a:xfrm>
-            <a:off x="9997227" y="5602072"/>
-            <a:ext cx="1899117" cy="478688"/>
+          <p:cNvPr id="160" name="Text 139"/>
+          <p:cNvSpPr txBox="1"/>
+          <p:nvPr/>
+        </p:nvSpPr>
+        <p:spPr>
+          <a:xfrm>
+            <a:off x="9988083" y="5602072"/>
+            <a:ext cx="1908261" cy="478688"/>
           </a:xfrm>
           <a:prstGeom prst="rect">
             <a:avLst/>
@@ -5968,14 +5845,14 @@
               <a:buNone/>
             </a:pPr>
             <a:r>
-              <a:rPr lang="en-US" sz="850" b="1" u="sng" dirty="0">
+              <a:rPr lang="en-US" sz="800" b="1" u="sng" dirty="0">
                 <a:solidFill>
                   <a:srgbClr val="E8434F"/>
                 </a:solidFill>
                 <a:latin typeface="Calibri" pitchFamily="34" charset="0"/>
                 <a:ea typeface="Calibri" pitchFamily="34" charset="-122"/>
                 <a:cs typeface="Calibri" pitchFamily="34" charset="-120"/>
-                <a:hlinkClick r:id="rId27" invalidUrl="" action="" tgtFrame="" tooltip="" history="1" highlightClick="0" endSnd="0">
+                <a:hlinkClick r:id="rId20" invalidUrl="" action="" tgtFrame="" tooltip="" history="1" highlightClick="0" endSnd="0">
                   <a:extLst>
                     <a:ext uri="{A12FA001-AC4F-418D-AE19-62706E023703}">
                       <ahyp:hlinkClr xmlns:ahyp="http://schemas.microsoft.com/office/drawing/2018/hyperlinkcolor" val="tx"/>
@@ -5985,14 +5862,14 @@
               </a:rPr>
               <a:t>meesho-dice-c2m-iitb.vercel.app</a:t>
             </a:r>
-            <a:endParaRPr lang="en-US" sz="700" dirty="0"/>
+            <a:endParaRPr lang="en-US" sz="650" dirty="0"/>
           </a:p>
           <a:p>
             <a:pPr indent="0" marL="0">
               <a:buNone/>
             </a:pPr>
             <a:r>
-              <a:rPr lang="en-US" sz="700" dirty="0">
+              <a:rPr lang="en-US" sz="650" dirty="0">
                 <a:solidFill>
                   <a:srgbClr val="1F1F1F"/>
                 </a:solidFill>
@@ -6002,14 +5879,31 @@
               </a:rPr>
               <a:t>Mirror: prathmesh-28.github.io/c2m-control-tower</a:t>
             </a:r>
-            <a:endParaRPr lang="en-US" sz="700" dirty="0"/>
+            <a:endParaRPr lang="en-US" sz="650" dirty="0"/>
           </a:p>
           <a:p>
             <a:pPr indent="0" marL="0">
               <a:buNone/>
             </a:pPr>
             <a:r>
-              <a:rPr lang="en-US" sz="700" dirty="0">
+              <a:rPr lang="en-US" sz="650" dirty="0">
+                <a:solidFill>
+                  <a:srgbClr val="1F1F1F"/>
+                </a:solidFill>
+                <a:latin typeface="Calibri" pitchFamily="34" charset="0"/>
+                <a:ea typeface="Calibri" pitchFamily="34" charset="-122"/>
+                <a:cs typeface="Calibri" pitchFamily="34" charset="-120"/>
+              </a:rPr>
+              <a:t>+ Meesho’s control tower: 3 more tabs</a:t>
+            </a:r>
+            <a:endParaRPr lang="en-US" sz="650" dirty="0"/>
+          </a:p>
+          <a:p>
+            <a:pPr indent="0" marL="0">
+              <a:buNone/>
+            </a:pPr>
+            <a:r>
+              <a:rPr lang="en-US" sz="650" dirty="0">
                 <a:solidFill>
                   <a:srgbClr val="6B6B6B"/>
                 </a:solidFill>
@@ -6017,9 +5911,9 @@
                 <a:ea typeface="Calibri" pitchFamily="34" charset="-122"/>
                 <a:cs typeface="Calibri" pitchFamily="34" charset="-120"/>
               </a:rPr>
-              <a:t>Offline: one HTML file in prototype/dist-single</a:t>
-            </a:r>
-            <a:endParaRPr lang="en-US" sz="700" dirty="0"/>
+              <a:t>261 synthetic sellers · 4,415 SKUs · 4 model tests</a:t>
+            </a:r>
+            <a:endParaRPr lang="en-US" sz="650" dirty="0"/>
           </a:p>
         </p:txBody>
       </p:sp>

</xml_diff>